<commit_message>
chore(presentation): update slide 7 QR code and notes to rescom-alert.site/download
</commit_message>
<xml_diff>
--- a/10RCDG_RESCOM_ALERT_Final.pptx
+++ b/10RCDG_RESCOM_ALERT_Final.pptx
@@ -397,7 +397,7 @@
           </a:p>
           <a:p>
             <a:r>
-              <a:t>It will take you directly to our live military download portal at https://rescom-alert.vercel.app/download.</a:t>
+              <a:t>It will take you directly to our live military download portal at https://rescom-alert.site/download.</a:t>
             </a:r>
           </a:p>
           <a:p>
@@ -611,7 +611,7 @@
           <a:p>
             <a:fld id="{5BCAD085-E8A6-8845-BD4E-CB4CCA059FC4}" type="datetimeFigureOut">
               <a:rPr lang="en-US" smtClean="0"/>
-              <a:t>10/5/2026</a:t>
+              <a:t>10/9/2026</a:t>
             </a:fld>
             <a:endParaRPr lang="en-US"/>
           </a:p>
@@ -779,7 +779,7 @@
           <a:p>
             <a:fld id="{5BCAD085-E8A6-8845-BD4E-CB4CCA059FC4}" type="datetimeFigureOut">
               <a:rPr lang="en-US" smtClean="0"/>
-              <a:t>10/5/2026</a:t>
+              <a:t>10/9/2026</a:t>
             </a:fld>
             <a:endParaRPr lang="en-US"/>
           </a:p>
@@ -957,7 +957,7 @@
           <a:p>
             <a:fld id="{5BCAD085-E8A6-8845-BD4E-CB4CCA059FC4}" type="datetimeFigureOut">
               <a:rPr lang="en-US" smtClean="0"/>
-              <a:t>10/5/2026</a:t>
+              <a:t>10/9/2026</a:t>
             </a:fld>
             <a:endParaRPr lang="en-US"/>
           </a:p>
@@ -1125,7 +1125,7 @@
           <a:p>
             <a:fld id="{5BCAD085-E8A6-8845-BD4E-CB4CCA059FC4}" type="datetimeFigureOut">
               <a:rPr lang="en-US" smtClean="0"/>
-              <a:t>10/5/2026</a:t>
+              <a:t>10/9/2026</a:t>
             </a:fld>
             <a:endParaRPr lang="en-US"/>
           </a:p>
@@ -1370,7 +1370,7 @@
           <a:p>
             <a:fld id="{5BCAD085-E8A6-8845-BD4E-CB4CCA059FC4}" type="datetimeFigureOut">
               <a:rPr lang="en-US" smtClean="0"/>
-              <a:t>10/5/2026</a:t>
+              <a:t>10/9/2026</a:t>
             </a:fld>
             <a:endParaRPr lang="en-US"/>
           </a:p>
@@ -1655,7 +1655,7 @@
           <a:p>
             <a:fld id="{5BCAD085-E8A6-8845-BD4E-CB4CCA059FC4}" type="datetimeFigureOut">
               <a:rPr lang="en-US" smtClean="0"/>
-              <a:t>10/5/2026</a:t>
+              <a:t>10/9/2026</a:t>
             </a:fld>
             <a:endParaRPr lang="en-US"/>
           </a:p>
@@ -2074,7 +2074,7 @@
           <a:p>
             <a:fld id="{5BCAD085-E8A6-8845-BD4E-CB4CCA059FC4}" type="datetimeFigureOut">
               <a:rPr lang="en-US" smtClean="0"/>
-              <a:t>10/5/2026</a:t>
+              <a:t>10/9/2026</a:t>
             </a:fld>
             <a:endParaRPr lang="en-US"/>
           </a:p>
@@ -2191,7 +2191,7 @@
           <a:p>
             <a:fld id="{5BCAD085-E8A6-8845-BD4E-CB4CCA059FC4}" type="datetimeFigureOut">
               <a:rPr lang="en-US" smtClean="0"/>
-              <a:t>10/5/2026</a:t>
+              <a:t>10/9/2026</a:t>
             </a:fld>
             <a:endParaRPr lang="en-US"/>
           </a:p>
@@ -2286,7 +2286,7 @@
           <a:p>
             <a:fld id="{5BCAD085-E8A6-8845-BD4E-CB4CCA059FC4}" type="datetimeFigureOut">
               <a:rPr lang="en-US" smtClean="0"/>
-              <a:t>10/5/2026</a:t>
+              <a:t>10/9/2026</a:t>
             </a:fld>
             <a:endParaRPr lang="en-US"/>
           </a:p>
@@ -2561,7 +2561,7 @@
           <a:p>
             <a:fld id="{5BCAD085-E8A6-8845-BD4E-CB4CCA059FC4}" type="datetimeFigureOut">
               <a:rPr lang="en-US" smtClean="0"/>
-              <a:t>10/5/2026</a:t>
+              <a:t>10/9/2026</a:t>
             </a:fld>
             <a:endParaRPr lang="en-US"/>
           </a:p>
@@ -2813,7 +2813,7 @@
           <a:p>
             <a:fld id="{5BCAD085-E8A6-8845-BD4E-CB4CCA059FC4}" type="datetimeFigureOut">
               <a:rPr lang="en-US" smtClean="0"/>
-              <a:t>10/5/2026</a:t>
+              <a:t>10/9/2026</a:t>
             </a:fld>
             <a:endParaRPr lang="en-US"/>
           </a:p>
@@ -3024,7 +3024,7 @@
           <a:p>
             <a:fld id="{5BCAD085-E8A6-8845-BD4E-CB4CCA059FC4}" type="datetimeFigureOut">
               <a:rPr lang="en-US" smtClean="0"/>
-              <a:t>10/5/2026</a:t>
+              <a:t>10/9/2026</a:t>
             </a:fld>
             <a:endParaRPr lang="en-US"/>
           </a:p>
@@ -3880,13 +3880,13 @@
   <p:clrMapOvr>
     <a:masterClrMapping/>
   </p:clrMapOvr>
-  <mc:AlternateContent xmlns:mc="http://schemas.openxmlformats.org/markup-compatibility/2006">
-    <mc:Choice xmlns:p159="http://schemas.microsoft.com/office/powerpoint/2015/09/main" Requires="p159">
+  <mc:AlternateContent xmlns:mc="http://schemas.openxmlformats.org/markup-compatibility/2006" xmlns:p159="http://schemas.microsoft.com/office/powerpoint/2015/09/main">
+    <mc:Choice Requires="p159">
       <p:transition xmlns:p14="http://schemas.microsoft.com/office/powerpoint/2010/main" spd="slow" p14:dur="2000">
         <p159:morph option="byObject"/>
       </p:transition>
     </mc:Choice>
-    <mc:Fallback>
+    <mc:Fallback xmlns="">
       <p:transition spd="slow">
         <p:fade/>
       </p:transition>
@@ -4567,13 +4567,13 @@
   <p:clrMapOvr>
     <a:masterClrMapping/>
   </p:clrMapOvr>
-  <mc:AlternateContent xmlns:mc="http://schemas.openxmlformats.org/markup-compatibility/2006">
-    <mc:Choice xmlns:p159="http://schemas.microsoft.com/office/powerpoint/2015/09/main" Requires="p159">
+  <mc:AlternateContent xmlns:mc="http://schemas.openxmlformats.org/markup-compatibility/2006" xmlns:p159="http://schemas.microsoft.com/office/powerpoint/2015/09/main">
+    <mc:Choice Requires="p159">
       <p:transition xmlns:p14="http://schemas.microsoft.com/office/powerpoint/2010/main" spd="slow" p14:dur="2000">
         <p159:morph option="byObject"/>
       </p:transition>
     </mc:Choice>
-    <mc:Fallback>
+    <mc:Fallback xmlns="">
       <p:transition spd="slow">
         <p:fade/>
       </p:transition>
@@ -5957,13 +5957,13 @@
   <p:clrMapOvr>
     <a:masterClrMapping/>
   </p:clrMapOvr>
-  <mc:AlternateContent xmlns:mc="http://schemas.openxmlformats.org/markup-compatibility/2006">
-    <mc:Choice xmlns:p159="http://schemas.microsoft.com/office/powerpoint/2015/09/main" Requires="p159">
+  <mc:AlternateContent xmlns:mc="http://schemas.openxmlformats.org/markup-compatibility/2006" xmlns:p159="http://schemas.microsoft.com/office/powerpoint/2015/09/main">
+    <mc:Choice Requires="p159">
       <p:transition xmlns:p14="http://schemas.microsoft.com/office/powerpoint/2010/main" spd="slow" p14:dur="2000">
         <p159:morph option="byObject"/>
       </p:transition>
     </mc:Choice>
-    <mc:Fallback>
+    <mc:Fallback xmlns="">
       <p:transition spd="slow">
         <p:fade/>
       </p:transition>
@@ -6901,13 +6901,13 @@
   <p:clrMapOvr>
     <a:masterClrMapping/>
   </p:clrMapOvr>
-  <mc:AlternateContent xmlns:mc="http://schemas.openxmlformats.org/markup-compatibility/2006">
-    <mc:Choice xmlns:p159="http://schemas.microsoft.com/office/powerpoint/2015/09/main" Requires="p159">
+  <mc:AlternateContent xmlns:mc="http://schemas.openxmlformats.org/markup-compatibility/2006" xmlns:p159="http://schemas.microsoft.com/office/powerpoint/2015/09/main">
+    <mc:Choice Requires="p159">
       <p:transition xmlns:p14="http://schemas.microsoft.com/office/powerpoint/2010/main" spd="slow" p14:dur="2000">
         <p159:morph option="byObject"/>
       </p:transition>
     </mc:Choice>
-    <mc:Fallback>
+    <mc:Fallback xmlns="">
       <p:transition spd="slow">
         <p:fade/>
       </p:transition>
@@ -7588,13 +7588,13 @@
   <p:clrMapOvr>
     <a:masterClrMapping/>
   </p:clrMapOvr>
-  <mc:AlternateContent xmlns:mc="http://schemas.openxmlformats.org/markup-compatibility/2006">
-    <mc:Choice xmlns:p159="http://schemas.microsoft.com/office/powerpoint/2015/09/main" Requires="p159">
+  <mc:AlternateContent xmlns:mc="http://schemas.openxmlformats.org/markup-compatibility/2006" xmlns:p159="http://schemas.microsoft.com/office/powerpoint/2015/09/main">
+    <mc:Choice Requires="p159">
       <p:transition xmlns:p14="http://schemas.microsoft.com/office/powerpoint/2010/main" spd="slow" p14:dur="2000">
         <p159:morph option="byObject"/>
       </p:transition>
     </mc:Choice>
-    <mc:Fallback>
+    <mc:Fallback xmlns="">
       <p:transition spd="slow">
         <p:fade/>
       </p:transition>
@@ -8182,13 +8182,13 @@
   <p:clrMapOvr>
     <a:masterClrMapping/>
   </p:clrMapOvr>
-  <mc:AlternateContent xmlns:mc="http://schemas.openxmlformats.org/markup-compatibility/2006">
-    <mc:Choice xmlns:p159="http://schemas.microsoft.com/office/powerpoint/2015/09/main" Requires="p159">
+  <mc:AlternateContent xmlns:mc="http://schemas.openxmlformats.org/markup-compatibility/2006" xmlns:p159="http://schemas.microsoft.com/office/powerpoint/2015/09/main">
+    <mc:Choice Requires="p159">
       <p:transition xmlns:p14="http://schemas.microsoft.com/office/powerpoint/2010/main" spd="slow" p14:dur="2000">
         <p159:morph option="byObject"/>
       </p:transition>
     </mc:Choice>
-    <mc:Fallback>
+    <mc:Fallback xmlns="">
       <p:transition spd="slow">
         <p:fade/>
       </p:transition>
@@ -8395,7 +8395,7 @@
         <p:spPr>
           <a:xfrm>
             <a:off x="1280160" y="2011680"/>
-            <a:ext cx="5486400" cy="2926080"/>
+            <a:ext cx="5486400" cy="1523494"/>
           </a:xfrm>
           <a:prstGeom prst="rect">
             <a:avLst/>
@@ -8416,6 +8416,7 @@
               </a:defRPr>
             </a:pPr>
             <a:r>
+              <a:rPr dirty="0"/>
               <a:t>Install &amp; Test on Your Phone Now</a:t>
             </a:r>
           </a:p>
@@ -8428,6 +8429,7 @@
               </a:defRPr>
             </a:pPr>
             <a:r>
+              <a:rPr dirty="0"/>
               <a:t>Official Public Mobile Download Portal:</a:t>
             </a:r>
           </a:p>
@@ -8440,7 +8442,16 @@
               </a:defRPr>
             </a:pPr>
             <a:r>
-              <a:t>👉 https://rescom-alert.vercel.app/download</a:t>
+              <a:rPr dirty="0"/>
+              <a:t>👉 https://rescom-alert.</a:t>
+            </a:r>
+            <a:r>
+              <a:rPr lang="en-US" dirty="0"/>
+              <a:t>site</a:t>
+            </a:r>
+            <a:r>
+              <a:rPr dirty="0"/>
+              <a:t>/download</a:t>
             </a:r>
           </a:p>
           <a:p>
@@ -8452,6 +8463,7 @@
               </a:defRPr>
             </a:pPr>
             <a:r>
+              <a:rPr dirty="0"/>
               <a:t>1. Open your phone camera and scan the QR code.</a:t>
             </a:r>
           </a:p>
@@ -8464,6 +8476,7 @@
               </a:defRPr>
             </a:pPr>
             <a:r>
+              <a:rPr dirty="0"/>
               <a:t>2. Tap 'DOWNLOAD SOLDIER APP' (No login required).</a:t>
             </a:r>
           </a:p>
@@ -8476,6 +8489,7 @@
               </a:defRPr>
             </a:pPr>
             <a:r>
+              <a:rPr dirty="0"/>
               <a:t>3. If prompted, tap 'Download anyway' (Official military APK).</a:t>
             </a:r>
           </a:p>
@@ -8488,6 +8502,7 @@
               </a:defRPr>
             </a:pPr>
             <a:r>
+              <a:rPr dirty="0"/>
               <a:t>4. Open app &amp; tap 'Enable' for Full-Screen Siren permissions.</a:t>
             </a:r>
           </a:p>
@@ -8542,10 +8557,6 @@
               </a:defRPr>
             </a:pPr>
             <a:r>
-              <a:rPr lang="en-ID" dirty="0"/>
-              <a:t>⚡</a:t>
-            </a:r>
-            <a:r>
               <a:rPr dirty="0"/>
               <a:t> LIVE DEDUPLICATION COUNTER DEMO:</a:t>
             </a:r>
@@ -8698,7 +8709,7 @@
         <p:spPr>
           <a:xfrm>
             <a:off x="7406640" y="4754880"/>
-            <a:ext cx="3200400" cy="731520"/>
+            <a:ext cx="3200400" cy="400110"/>
           </a:xfrm>
           <a:prstGeom prst="rect">
             <a:avLst/>
@@ -8719,6 +8730,7 @@
               </a:defRPr>
             </a:pPr>
             <a:r>
+              <a:rPr dirty="0"/>
               <a:t>Compatible with Android 7.0 to Android 15+</a:t>
             </a:r>
           </a:p>
@@ -8731,8 +8743,14 @@
               </a:defRPr>
             </a:pPr>
             <a:r>
-              <a:t>Javier Siliacay • USTP Autotronics</a:t>
-            </a:r>
+              <a:rPr dirty="0"/>
+              <a:t>Javier Siliacay • </a:t>
+            </a:r>
+            <a:r>
+              <a:rPr lang="en-US" dirty="0"/>
+              <a:t>Developer</a:t>
+            </a:r>
+            <a:endParaRPr dirty="0"/>
           </a:p>
         </p:txBody>
       </p:sp>
@@ -8741,13 +8759,13 @@
   <p:clrMapOvr>
     <a:masterClrMapping/>
   </p:clrMapOvr>
-  <mc:AlternateContent xmlns:mc="http://schemas.openxmlformats.org/markup-compatibility/2006">
-    <mc:Choice xmlns:p159="http://schemas.microsoft.com/office/powerpoint/2015/09/main" Requires="p159">
+  <mc:AlternateContent xmlns:mc="http://schemas.openxmlformats.org/markup-compatibility/2006" xmlns:p159="http://schemas.microsoft.com/office/powerpoint/2015/09/main">
+    <mc:Choice Requires="p159">
       <p:transition xmlns:p14="http://schemas.microsoft.com/office/powerpoint/2010/main" spd="slow" p14:dur="2000">
         <p159:morph option="byObject"/>
       </p:transition>
     </mc:Choice>
-    <mc:Fallback>
+    <mc:Fallback xmlns="">
       <p:transition spd="slow">
         <p:fade/>
       </p:transition>

</xml_diff>

<commit_message>
feat: complete enlistment safeguards, troop pagination, and multi-channel alert routing
</commit_message>
<xml_diff>
--- a/10RCDG_RESCOM_ALERT_Final.pptx
+++ b/10RCDG_RESCOM_ALERT_Final.pptx
@@ -611,7 +611,7 @@
           <a:p>
             <a:fld id="{5BCAD085-E8A6-8845-BD4E-CB4CCA059FC4}" type="datetimeFigureOut">
               <a:rPr lang="en-US" smtClean="0"/>
-              <a:t>10/9/2026</a:t>
+              <a:t>10/10/2026</a:t>
             </a:fld>
             <a:endParaRPr lang="en-US"/>
           </a:p>
@@ -779,7 +779,7 @@
           <a:p>
             <a:fld id="{5BCAD085-E8A6-8845-BD4E-CB4CCA059FC4}" type="datetimeFigureOut">
               <a:rPr lang="en-US" smtClean="0"/>
-              <a:t>10/9/2026</a:t>
+              <a:t>10/10/2026</a:t>
             </a:fld>
             <a:endParaRPr lang="en-US"/>
           </a:p>
@@ -957,7 +957,7 @@
           <a:p>
             <a:fld id="{5BCAD085-E8A6-8845-BD4E-CB4CCA059FC4}" type="datetimeFigureOut">
               <a:rPr lang="en-US" smtClean="0"/>
-              <a:t>10/9/2026</a:t>
+              <a:t>10/10/2026</a:t>
             </a:fld>
             <a:endParaRPr lang="en-US"/>
           </a:p>
@@ -1125,7 +1125,7 @@
           <a:p>
             <a:fld id="{5BCAD085-E8A6-8845-BD4E-CB4CCA059FC4}" type="datetimeFigureOut">
               <a:rPr lang="en-US" smtClean="0"/>
-              <a:t>10/9/2026</a:t>
+              <a:t>10/10/2026</a:t>
             </a:fld>
             <a:endParaRPr lang="en-US"/>
           </a:p>
@@ -1370,7 +1370,7 @@
           <a:p>
             <a:fld id="{5BCAD085-E8A6-8845-BD4E-CB4CCA059FC4}" type="datetimeFigureOut">
               <a:rPr lang="en-US" smtClean="0"/>
-              <a:t>10/9/2026</a:t>
+              <a:t>10/10/2026</a:t>
             </a:fld>
             <a:endParaRPr lang="en-US"/>
           </a:p>
@@ -1655,7 +1655,7 @@
           <a:p>
             <a:fld id="{5BCAD085-E8A6-8845-BD4E-CB4CCA059FC4}" type="datetimeFigureOut">
               <a:rPr lang="en-US" smtClean="0"/>
-              <a:t>10/9/2026</a:t>
+              <a:t>10/10/2026</a:t>
             </a:fld>
             <a:endParaRPr lang="en-US"/>
           </a:p>
@@ -2074,7 +2074,7 @@
           <a:p>
             <a:fld id="{5BCAD085-E8A6-8845-BD4E-CB4CCA059FC4}" type="datetimeFigureOut">
               <a:rPr lang="en-US" smtClean="0"/>
-              <a:t>10/9/2026</a:t>
+              <a:t>10/10/2026</a:t>
             </a:fld>
             <a:endParaRPr lang="en-US"/>
           </a:p>
@@ -2191,7 +2191,7 @@
           <a:p>
             <a:fld id="{5BCAD085-E8A6-8845-BD4E-CB4CCA059FC4}" type="datetimeFigureOut">
               <a:rPr lang="en-US" smtClean="0"/>
-              <a:t>10/9/2026</a:t>
+              <a:t>10/10/2026</a:t>
             </a:fld>
             <a:endParaRPr lang="en-US"/>
           </a:p>
@@ -2286,7 +2286,7 @@
           <a:p>
             <a:fld id="{5BCAD085-E8A6-8845-BD4E-CB4CCA059FC4}" type="datetimeFigureOut">
               <a:rPr lang="en-US" smtClean="0"/>
-              <a:t>10/9/2026</a:t>
+              <a:t>10/10/2026</a:t>
             </a:fld>
             <a:endParaRPr lang="en-US"/>
           </a:p>
@@ -2561,7 +2561,7 @@
           <a:p>
             <a:fld id="{5BCAD085-E8A6-8845-BD4E-CB4CCA059FC4}" type="datetimeFigureOut">
               <a:rPr lang="en-US" smtClean="0"/>
-              <a:t>10/9/2026</a:t>
+              <a:t>10/10/2026</a:t>
             </a:fld>
             <a:endParaRPr lang="en-US"/>
           </a:p>
@@ -2813,7 +2813,7 @@
           <a:p>
             <a:fld id="{5BCAD085-E8A6-8845-BD4E-CB4CCA059FC4}" type="datetimeFigureOut">
               <a:rPr lang="en-US" smtClean="0"/>
-              <a:t>10/9/2026</a:t>
+              <a:t>10/10/2026</a:t>
             </a:fld>
             <a:endParaRPr lang="en-US"/>
           </a:p>
@@ -3024,7 +3024,7 @@
           <a:p>
             <a:fld id="{5BCAD085-E8A6-8845-BD4E-CB4CCA059FC4}" type="datetimeFigureOut">
               <a:rPr lang="en-US" smtClean="0"/>
-              <a:t>10/9/2026</a:t>
+              <a:t>10/10/2026</a:t>
             </a:fld>
             <a:endParaRPr lang="en-US"/>
           </a:p>
@@ -3580,7 +3580,7 @@
         <p:spPr>
           <a:xfrm>
             <a:off x="1828800" y="2606040"/>
-            <a:ext cx="8534095" cy="1463040"/>
+            <a:ext cx="8534095" cy="1138773"/>
           </a:xfrm>
           <a:prstGeom prst="rect">
             <a:avLst/>
@@ -3601,8 +3601,14 @@
               </a:defRPr>
             </a:pPr>
             <a:r>
+              <a:rPr dirty="0"/>
               <a:t>10RCDG RESCOM ALERT</a:t>
             </a:r>
+            <a:r>
+              <a:rPr lang="en-US" dirty="0"/>
+              <a:t> APP</a:t>
+            </a:r>
+            <a:endParaRPr dirty="0"/>
           </a:p>
           <a:p>
             <a:pPr algn="ctr">
@@ -3613,6 +3619,7 @@
               </a:defRPr>
             </a:pPr>
             <a:r>
+              <a:rPr dirty="0"/>
               <a:t>Tactical Mass Emergency Siren &amp; Rapid Mobilization Notification Architecture</a:t>
             </a:r>
           </a:p>
@@ -3625,8 +3632,14 @@
               </a:defRPr>
             </a:pPr>
             <a:r>
-              <a:t>10th Regional Community Defense Group  •  Camp General Manuel T Yan Sr, Mawab</a:t>
-            </a:r>
+              <a:rPr dirty="0"/>
+              <a:t>10th Regional Community Defense Group  •  Camp General Manuel T Yan Sr, </a:t>
+            </a:r>
+            <a:r>
+              <a:rPr dirty="0" err="1"/>
+              <a:t>Mawab</a:t>
+            </a:r>
+            <a:endParaRPr dirty="0"/>
           </a:p>
         </p:txBody>
       </p:sp>

</xml_diff>